<commit_message>
updated PPT, Word and PDF files
</commit_message>
<xml_diff>
--- a/02/02_eloadas_HTTP_mukodese.pptx
+++ b/02/02_eloadas_HTTP_mukodese.pptx
@@ -10385,53 +10385,6 @@
               <a:rPr lang="en-US" dirty="0"/>
               <a:t>.</a:t>
             </a:r>
-            <a:br>
-              <a:rPr lang="en-US" dirty="0"/>
-            </a:br>
-            <a:r>
-              <a:rPr lang="en-US" dirty="0"/>
-              <a:t>Ez </a:t>
-            </a:r>
-            <a:r>
-              <a:rPr lang="en-US" dirty="0" err="1"/>
-              <a:t>akár</a:t>
-            </a:r>
-            <a:r>
-              <a:rPr lang="en-US" dirty="0"/>
-              <a:t> </a:t>
-            </a:r>
-            <a:r>
-              <a:rPr lang="en-US" dirty="0" err="1"/>
-              <a:t>több</a:t>
-            </a:r>
-            <a:r>
-              <a:rPr lang="en-US" dirty="0"/>
-              <a:t> mint 50%-kal </a:t>
-            </a:r>
-            <a:r>
-              <a:rPr lang="en-US" dirty="0" err="1"/>
-              <a:t>gyorsítja</a:t>
-            </a:r>
-            <a:r>
-              <a:rPr lang="en-US" dirty="0"/>
-              <a:t> a </a:t>
-            </a:r>
-            <a:r>
-              <a:rPr lang="en-US" dirty="0" err="1"/>
-              <a:t>weboldalak</a:t>
-            </a:r>
-            <a:r>
-              <a:rPr lang="en-US" dirty="0"/>
-              <a:t> </a:t>
-            </a:r>
-            <a:r>
-              <a:rPr lang="en-US" dirty="0" err="1"/>
-              <a:t>betöltését</a:t>
-            </a:r>
-            <a:r>
-              <a:rPr lang="en-US" dirty="0"/>
-              <a:t>.</a:t>
-            </a:r>
           </a:p>
           <a:p>
             <a:endParaRPr lang="hu-HU" dirty="0"/>
@@ -11415,7 +11368,7 @@
           <a:p>
             <a:fld id="{5BCAD085-E8A6-8845-BD4E-CB4CCA059FC4}" type="datetimeFigureOut">
               <a:rPr lang="en-US" smtClean="0"/>
-              <a:t>2/16/2026</a:t>
+              <a:t>2/22/2026</a:t>
             </a:fld>
             <a:endParaRPr lang="en-US"/>
           </a:p>
@@ -11583,7 +11536,7 @@
           <a:p>
             <a:fld id="{5BCAD085-E8A6-8845-BD4E-CB4CCA059FC4}" type="datetimeFigureOut">
               <a:rPr lang="en-US" smtClean="0"/>
-              <a:t>2/16/2026</a:t>
+              <a:t>2/22/2026</a:t>
             </a:fld>
             <a:endParaRPr lang="en-US"/>
           </a:p>
@@ -11761,7 +11714,7 @@
           <a:p>
             <a:fld id="{5BCAD085-E8A6-8845-BD4E-CB4CCA059FC4}" type="datetimeFigureOut">
               <a:rPr lang="en-US" smtClean="0"/>
-              <a:t>2/16/2026</a:t>
+              <a:t>2/22/2026</a:t>
             </a:fld>
             <a:endParaRPr lang="en-US"/>
           </a:p>
@@ -11929,7 +11882,7 @@
           <a:p>
             <a:fld id="{5BCAD085-E8A6-8845-BD4E-CB4CCA059FC4}" type="datetimeFigureOut">
               <a:rPr lang="en-US" smtClean="0"/>
-              <a:t>2/16/2026</a:t>
+              <a:t>2/22/2026</a:t>
             </a:fld>
             <a:endParaRPr lang="en-US"/>
           </a:p>
@@ -12174,7 +12127,7 @@
           <a:p>
             <a:fld id="{5BCAD085-E8A6-8845-BD4E-CB4CCA059FC4}" type="datetimeFigureOut">
               <a:rPr lang="en-US" smtClean="0"/>
-              <a:t>2/16/2026</a:t>
+              <a:t>2/22/2026</a:t>
             </a:fld>
             <a:endParaRPr lang="en-US"/>
           </a:p>
@@ -12459,7 +12412,7 @@
           <a:p>
             <a:fld id="{5BCAD085-E8A6-8845-BD4E-CB4CCA059FC4}" type="datetimeFigureOut">
               <a:rPr lang="en-US" smtClean="0"/>
-              <a:t>2/16/2026</a:t>
+              <a:t>2/22/2026</a:t>
             </a:fld>
             <a:endParaRPr lang="en-US"/>
           </a:p>
@@ -12878,7 +12831,7 @@
           <a:p>
             <a:fld id="{5BCAD085-E8A6-8845-BD4E-CB4CCA059FC4}" type="datetimeFigureOut">
               <a:rPr lang="en-US" smtClean="0"/>
-              <a:t>2/16/2026</a:t>
+              <a:t>2/22/2026</a:t>
             </a:fld>
             <a:endParaRPr lang="en-US"/>
           </a:p>
@@ -12995,7 +12948,7 @@
           <a:p>
             <a:fld id="{5BCAD085-E8A6-8845-BD4E-CB4CCA059FC4}" type="datetimeFigureOut">
               <a:rPr lang="en-US" smtClean="0"/>
-              <a:t>2/16/2026</a:t>
+              <a:t>2/22/2026</a:t>
             </a:fld>
             <a:endParaRPr lang="en-US"/>
           </a:p>
@@ -13090,7 +13043,7 @@
           <a:p>
             <a:fld id="{5BCAD085-E8A6-8845-BD4E-CB4CCA059FC4}" type="datetimeFigureOut">
               <a:rPr lang="en-US" smtClean="0"/>
-              <a:t>2/16/2026</a:t>
+              <a:t>2/22/2026</a:t>
             </a:fld>
             <a:endParaRPr lang="en-US"/>
           </a:p>
@@ -13365,7 +13318,7 @@
           <a:p>
             <a:fld id="{5BCAD085-E8A6-8845-BD4E-CB4CCA059FC4}" type="datetimeFigureOut">
               <a:rPr lang="en-US" smtClean="0"/>
-              <a:t>2/16/2026</a:t>
+              <a:t>2/22/2026</a:t>
             </a:fld>
             <a:endParaRPr lang="en-US"/>
           </a:p>
@@ -13617,7 +13570,7 @@
           <a:p>
             <a:fld id="{5BCAD085-E8A6-8845-BD4E-CB4CCA059FC4}" type="datetimeFigureOut">
               <a:rPr lang="en-US" smtClean="0"/>
-              <a:t>2/16/2026</a:t>
+              <a:t>2/22/2026</a:t>
             </a:fld>
             <a:endParaRPr lang="en-US"/>
           </a:p>
@@ -13828,7 +13781,7 @@
           <a:p>
             <a:fld id="{5BCAD085-E8A6-8845-BD4E-CB4CCA059FC4}" type="datetimeFigureOut">
               <a:rPr lang="en-US" smtClean="0"/>
-              <a:t>2/16/2026</a:t>
+              <a:t>2/22/2026</a:t>
             </a:fld>
             <a:endParaRPr lang="en-US"/>
           </a:p>

</xml_diff>